<commit_message>
De-Claude PPT submission: declarative titles, numeric consistency
- Convert four question-form result titles (S6, S8, S9, S11) to finding statements.
- Soften ALL-CAPS labels; replace status glyphs with text legend on S12;
  redistribute em-dash constructions to colons/periods.
- Temper causal-overreach phrasing on S7 to pattern/observation framing.
- Reconcile corpus figures to the S4 funnel (1,287,761 / 480,972) on S10 chips;
  fix S8 page number 9->8. Content unchanged; tone, labels, and figure
  consistency only. No raw post text or IDs.
</commit_message>
<xml_diff>
--- a/ppt/HighFive_Step3_Submission.pptx
+++ b/ppt/HighFive_Step3_Submission.pptx
@@ -2047,7 +2047,7 @@
                 <a:ea typeface="Calibri" pitchFamily="34" charset="-122"/>
                 <a:cs typeface="Calibri" pitchFamily="34" charset="-120"/>
               </a:rPr>
-              <a:t>Seoul — a hard case for testing UMC.</a:t>
+              <a:t>Seoul: a demanding test case for universal meaningful connectivity.</a:t>
             </a:r>
             <a:endParaRPr lang="en-US" sz="2000" dirty="0"/>
           </a:p>
@@ -2166,7 +2166,7 @@
                 <a:ea typeface="Calibri" pitchFamily="34" charset="-122"/>
                 <a:cs typeface="Calibri" pitchFamily="34" charset="-120"/>
               </a:rPr>
-              <a:t>. Seoul is therefore the natural setting for asking how UMC should be defined and measured beyond infrastructure.</a:t>
+              <a:t>. Seoul therefore offers a setting for asking how UMC should be defined and measured beyond infrastructure.</a:t>
             </a:r>
             <a:endParaRPr lang="en-US" sz="1400" dirty="0"/>
           </a:p>
@@ -3458,7 +3458,7 @@
                 <a:ea typeface="Calibri" pitchFamily="34" charset="-122"/>
                 <a:cs typeface="Calibri" pitchFamily="34" charset="-120"/>
               </a:rPr>
-              <a:t>Where infrastructure indicators may miss the problem</a:t>
+              <a:t>Where measured indicators and platform signals diverge</a:t>
             </a:r>
             <a:endParaRPr lang="en-US" sz="3000" dirty="0"/>
           </a:p>
@@ -4449,7 +4449,7 @@
                   <a:ea typeface="Calibri" pitchFamily="34" charset="-122"/>
                   <a:cs typeface="Calibri" pitchFamily="34" charset="-120"/>
                 </a:rPr>
-                <a:t>POSITIVE shift</a:t>
+                <a:t>Positive shift</a:t>
               </a:r>
               <a:r>
                 <a:rPr lang="en-US" sz="1600" dirty="0">
@@ -4500,7 +4500,7 @@
                   <a:ea typeface="Calibri" pitchFamily="34" charset="-122"/>
                   <a:cs typeface="Calibri" pitchFamily="34" charset="-120"/>
                 </a:rPr>
-                <a:t>NEGATIVE shift</a:t>
+                <a:t>Negative shift</a:t>
               </a:r>
               <a:r>
                 <a:rPr lang="en-US" sz="1600" dirty="0">
@@ -4766,7 +4766,7 @@
                   <a:ea typeface="Calibri" pitchFamily="34" charset="-122"/>
                   <a:cs typeface="Calibri" pitchFamily="34" charset="-120"/>
                 </a:rPr>
-                <a:t>1.29M</a:t>
+                <a:t>1,287,761</a:t>
               </a:r>
               <a:endParaRPr lang="en-US" sz="2600" dirty="0"/>
             </a:p>
@@ -4879,7 +4879,7 @@
                   <a:ea typeface="Calibri" pitchFamily="34" charset="-122"/>
                   <a:cs typeface="Calibri" pitchFamily="34" charset="-120"/>
                 </a:rPr>
-                <a:t>~520k</a:t>
+                <a:t>480,972</a:t>
               </a:r>
               <a:endParaRPr lang="en-US" sz="2600" dirty="0"/>
             </a:p>
@@ -5205,7 +5205,7 @@
                 <a:ea typeface="Calibri" pitchFamily="34" charset="-122"/>
                 <a:cs typeface="Calibri" pitchFamily="34" charset="-120"/>
               </a:rPr>
-              <a:t>How is the gap experienced?</a:t>
+              <a:t>Deprivation signatures in community discourse</a:t>
             </a:r>
             <a:endParaRPr lang="en-US" sz="3000" dirty="0"/>
           </a:p>
@@ -5268,7 +5268,7 @@
                 <a:ea typeface="Calibri" pitchFamily="34" charset="-122"/>
                 <a:cs typeface="Calibri" pitchFamily="34" charset="-120"/>
               </a:rPr>
-              <a:t>Platform text analysis — deprivation patterns from ~520k community posts.</a:t>
+              <a:t>Platform text analysis: deprivation patterns across the screened community-post sample.</a:t>
             </a:r>
             <a:endParaRPr lang="en-US" sz="1400" dirty="0"/>
           </a:p>
@@ -5520,7 +5520,7 @@
                   <a:ea typeface="Calibri" pitchFamily="34" charset="-122"/>
                   <a:cs typeface="Calibri" pitchFamily="34" charset="-120"/>
                 </a:rPr>
-                <a:t>Deprivation Types (n=100) — 88% of posts overlap 2 or more types.</a:t>
+                <a:t>Deprivation types (n=100): 88% of posts overlap two or more types.</a:t>
               </a:r>
               <a:endParaRPr lang="en-US" altLang="ko-KR" sz="1200" dirty="0"/>
             </a:p>
@@ -5586,7 +5586,7 @@
                   <a:ea typeface="Calibri" pitchFamily="34" charset="-122"/>
                   <a:cs typeface="Calibri" pitchFamily="34" charset="-120"/>
                 </a:rPr>
-                <a:t>REPRESENTATIVE CASES</a:t>
+                <a:t>Representative cases</a:t>
               </a:r>
               <a:endParaRPr lang="en-US" dirty="0"/>
             </a:p>
@@ -6151,7 +6151,7 @@
                 <a:ea typeface="Calibri" pitchFamily="34" charset="-122"/>
                 <a:cs typeface="Calibri" pitchFamily="34" charset="-120"/>
               </a:rPr>
-              <a:t>✓  ANALYSIS COMPLETE</a:t>
+              <a:t>Complete — Analysis</a:t>
             </a:r>
             <a:endParaRPr lang="en-US" sz="1000" dirty="0"/>
           </a:p>
@@ -6421,7 +6421,7 @@
                 <a:ea typeface="Calibri" pitchFamily="34" charset="-122"/>
                 <a:cs typeface="Calibri" pitchFamily="34" charset="-120"/>
               </a:rPr>
-              <a:t>◐  MAIN RESULTS DRAFTED</a:t>
+              <a:t>In progress — Main results drafted</a:t>
             </a:r>
             <a:endParaRPr lang="en-US" sz="1000" dirty="0"/>
           </a:p>
@@ -6691,7 +6691,7 @@
                 <a:ea typeface="Calibri" pitchFamily="34" charset="-122"/>
                 <a:cs typeface="Calibri" pitchFamily="34" charset="-120"/>
               </a:rPr>
-              <a:t>◑  PHASE 2 IN PROGRESS</a:t>
+              <a:t>In progress — Phase 2</a:t>
             </a:r>
             <a:endParaRPr lang="en-US" sz="1000" dirty="0"/>
           </a:p>
@@ -16485,7 +16485,7 @@
                 <a:ea typeface="Calibri" pitchFamily="34" charset="-122"/>
                 <a:cs typeface="Calibri" pitchFamily="34" charset="-120"/>
               </a:rPr>
-              <a:t>Preliminary results — Where is the gap?</a:t>
+              <a:t>Geographic distribution of connectivity gaps across districts</a:t>
             </a:r>
             <a:endParaRPr lang="en-US" sz="3000" dirty="0"/>
           </a:p>
@@ -18965,7 +18965,7 @@
                   <a:ea typeface="Calibri" pitchFamily="34" charset="-122"/>
                   <a:cs typeface="Calibri" pitchFamily="34" charset="-120"/>
                 </a:rPr>
-                <a:t>Physical infrastructure exists — what is missing is human and economic capacity</a:t>
+                <a:t>Infrastructure measures are present, while human and economic capacity gaps remain</a:t>
               </a:r>
               <a:endParaRPr lang="en-US" sz="1400" dirty="0"/>
             </a:p>
@@ -19009,7 +19009,7 @@
                   <a:ea typeface="Calibri" pitchFamily="34" charset="-122"/>
                   <a:cs typeface="Calibri" pitchFamily="34" charset="-120"/>
                 </a:rPr>
-                <a:t>Implication: dimension-specific intervention, not uniform infrastructure investment</a:t>
+                <a:t>Pattern suggests dimension-specific targeting as a testable direction, not a causal conclusion</a:t>
               </a:r>
               <a:endParaRPr lang="en-US" sz="1400" dirty="0"/>
             </a:p>
@@ -19251,7 +19251,7 @@
                 <a:ea typeface="Calibri" pitchFamily="34" charset="-122"/>
                 <a:cs typeface="Calibri" pitchFamily="34" charset="-120"/>
               </a:rPr>
-              <a:t>Why does the gap exist? — Individual differences dominate</a:t>
+              <a:t>Individual-level factors account for most variation in digital use</a:t>
             </a:r>
             <a:endParaRPr lang="en-US" sz="3000" dirty="0"/>
           </a:p>
@@ -19356,7 +19356,7 @@
                 <a:ea typeface="Calibri" pitchFamily="34" charset="-122"/>
                 <a:cs typeface="Calibri" pitchFamily="34" charset="-120"/>
               </a:rPr>
-              <a:t>WHERE THE GAP LIVES</a:t>
+              <a:t>Where the variation sits</a:t>
             </a:r>
             <a:endParaRPr lang="en-US" sz="1600" dirty="0"/>
           </a:p>
@@ -19508,7 +19508,7 @@
                 <a:ea typeface="Calibri" pitchFamily="34" charset="-122"/>
                 <a:cs typeface="Calibri" pitchFamily="34" charset="-120"/>
               </a:rPr>
-              <a:t>STRONGEST PREDICTORS</a:t>
+              <a:t>Strongest individual-level associations</a:t>
             </a:r>
             <a:endParaRPr lang="en-US" sz="1400" dirty="0"/>
           </a:p>
@@ -20348,7 +20348,7 @@
                 <a:ea typeface="Calibri" pitchFamily="34" charset="-122"/>
                 <a:cs typeface="Calibri" pitchFamily="34" charset="-120"/>
               </a:rPr>
-              <a:t>9 / 13</a:t>
+              <a:t>8 / 13</a:t>
             </a:r>
             <a:endParaRPr lang="en-US" sz="900" dirty="0"/>
           </a:p>
@@ -20531,7 +20531,7 @@
                 <a:ea typeface="Calibri" pitchFamily="34" charset="-122"/>
                 <a:cs typeface="Calibri" pitchFamily="34" charset="-120"/>
               </a:rPr>
-              <a:t>Does infrastructure offset individual vulnerability?</a:t>
+              <a:t>Limited cross-level associations between district infrastructure and individual use</a:t>
             </a:r>
             <a:endParaRPr lang="en-US" sz="3000" dirty="0"/>
           </a:p>
@@ -20675,7 +20675,7 @@
                 <a:ea typeface="Calibri" pitchFamily="34" charset="-122"/>
                 <a:cs typeface="Calibri" pitchFamily="34" charset="-120"/>
               </a:rPr>
-              <a:t>MAIN EFFECT</a:t>
+              <a:t>Main effect</a:t>
             </a:r>
             <a:endParaRPr lang="en-US" sz="1600" dirty="0"/>
           </a:p>
@@ -20783,7 +20783,7 @@
                 <a:ea typeface="Calibri" pitchFamily="34" charset="-122"/>
                 <a:cs typeface="Calibri" pitchFamily="34" charset="-120"/>
               </a:rPr>
-              <a:t>CROSS-LEVEL INTERACTIONS</a:t>
+              <a:t>Cross-level interactions</a:t>
             </a:r>
             <a:endParaRPr lang="en-US" sz="1400" dirty="0"/>
           </a:p>
@@ -21163,7 +21163,7 @@
                 <a:ea typeface="Calibri" pitchFamily="34" charset="-122"/>
                 <a:cs typeface="Calibri" pitchFamily="34" charset="-120"/>
               </a:rPr>
-              <a:t>INTERPRETATION</a:t>
+              <a:t>Interpretation</a:t>
             </a:r>
             <a:endParaRPr lang="en-US" sz="1600" dirty="0"/>
           </a:p>
@@ -21208,7 +21208,7 @@
                 <a:ea typeface="Calibri" pitchFamily="34" charset="-122"/>
                 <a:cs typeface="Calibri" pitchFamily="34" charset="-120"/>
               </a:rPr>
-              <a:t>Retained interactions are individual-level: the low-education penalty steepens with age (Age × low education −0.40***, M3) and with being 65+ (Older × low education −3.53*, M4 supplementary). District-level UMC dimensions show only weak, marginal main associations (Connectivity −1.34†, Affordability −1.35† in M3); the Connectivity × low-education term is positive but non-significant (+4.66, p=.16). District scores locate where vulnerable residents concentrate — supporting place-sensitive (not place-based) targeting.</a:t>
+              <a:t>Retained interactions are individual-level: the low-education penalty steepens with age (Age × low education −0.40***, M3) and with being 65+ (Older × low education −3.53*, M4 supplementary). District-level UMC dimensions show only weak, marginal main associations (Connectivity −1.34†, Affordability −1.35† in M3); the Connectivity × low-education term is positive but non-significant (+4.66, p=.16). District scores locate where vulnerable residents concentrate, supporting place-sensitive (not place-based) targeting.</a:t>
             </a:r>
             <a:endParaRPr lang="en-US" sz="1200" dirty="0"/>
           </a:p>

</xml_diff>